<commit_message>
Record the combined harness after Karatsuba landed.
Schoolbook, Karatsuba, FFT, the OpenAI function, and GMP are timed on the same Ryzen machine through 16384 limbs.
</commit_message>
<xml_diff>
--- a/Deliverables/bailey-video.pptx
+++ b/Deliverables/bailey-video.pptx
@@ -3314,7 +3314,7 @@
               </a:spcAft>
             </a:pPr>
             <a:r>
-              <a:rPr sz="2600" b="0">
+              <a:rPr sz="2400" b="0">
                 <a:solidFill>
                   <a:srgbClr val="1C1917"/>
                 </a:solidFill>
@@ -3330,13 +3330,13 @@
               </a:spcAft>
             </a:pPr>
             <a:r>
-              <a:rPr sz="2600" b="0">
+              <a:rPr sz="2400" b="0">
                 <a:solidFill>
                   <a:srgbClr val="1C1917"/>
                 </a:solidFill>
                 <a:latin typeface="Calibri"/>
               </a:rPr>
-              <a:t>Mine stays on 16-bit digits.</a:t>
+              <a:t>Mine stays on 16-bit digits. On this run I only edge it at 16,384 limbs.</a:t>
             </a:r>
           </a:p>
           <a:p>
@@ -3346,13 +3346,13 @@
               </a:spcAft>
             </a:pPr>
             <a:r>
-              <a:rPr sz="2600" b="0">
+              <a:rPr sz="2400" b="0">
                 <a:solidFill>
                   <a:srgbClr val="1C1917"/>
                 </a:solidFill>
                 <a:latin typeface="Calibri"/>
               </a:rPr>
-              <a:t>Next: build the twiddle powers in setup, outside the timer.</a:t>
+              <a:t>Karatsuba is faster than both of those at that size.</a:t>
             </a:r>
           </a:p>
           <a:p>
@@ -3362,7 +3362,23 @@
               </a:spcAft>
             </a:pPr>
             <a:r>
-              <a:rPr sz="2600" b="0">
+              <a:rPr sz="2400" b="0">
+                <a:solidFill>
+                  <a:srgbClr val="1C1917"/>
+                </a:solidFill>
+                <a:latin typeface="Calibri"/>
+              </a:rPr>
+              <a:t>Next: build the twiddle powers in setup, outside the timer.</a:t>
+            </a:r>
+          </a:p>
+          <a:p>
+            <a:pPr>
+              <a:spcAft>
+                <a:spcPts val="1400"/>
+              </a:spcAft>
+            </a:pPr>
+            <a:r>
+              <a:rPr sz="2400" b="0">
                 <a:solidFill>
                   <a:srgbClr val="1C1917"/>
                 </a:solidFill>
@@ -4284,7 +4300,7 @@
                 </a:solidFill>
                 <a:latin typeface="Calibri"/>
               </a:rPr>
-              <a:t>Dashed lines: 4,096 limbs (passes schoolbook) and 8,192 limbs (passes the FFT).</a:t>
+              <a:t>Same run, after Karatsuba was merged. Dashed lines mark 4,096 and 8,192 limbs.</a:t>
             </a:r>
           </a:p>
         </p:txBody>
@@ -4377,13 +4393,13 @@
               </a:spcAft>
             </a:pPr>
             <a:r>
-              <a:rPr sz="2400" b="0">
+              <a:rPr sz="2200" b="0">
                 <a:solidFill>
                   <a:srgbClr val="1C1917"/>
                 </a:solidFill>
                 <a:latin typeface="Calibri"/>
               </a:rPr>
-              <a:t>GMP is fastest on every row. At 16,384 limbs it is about 15 times faster than mine.</a:t>
+              <a:t>GMP is fastest on every row. At 16,384 limbs it is about 17 times faster than mine.</a:t>
             </a:r>
           </a:p>
           <a:p>
@@ -4393,13 +4409,13 @@
               </a:spcAft>
             </a:pPr>
             <a:r>
-              <a:rPr sz="2400" b="0">
+              <a:rPr sz="2200" b="0">
                 <a:solidFill>
                   <a:srgbClr val="1C1917"/>
                 </a:solidFill>
                 <a:latin typeface="Calibri"/>
               </a:rPr>
-              <a:t>I pass schoolbook at 4,096 limbs: 10.2 ms against 15.5 ms.</a:t>
+              <a:t>Karatsuba is faster than mine at every size in this table.</a:t>
             </a:r>
           </a:p>
           <a:p>
@@ -4409,13 +4425,13 @@
               </a:spcAft>
             </a:pPr>
             <a:r>
-              <a:rPr sz="2400" b="0">
+              <a:rPr sz="2200" b="0">
                 <a:solidFill>
                   <a:srgbClr val="1C1917"/>
                 </a:solidFill>
                 <a:latin typeface="Calibri"/>
               </a:rPr>
-              <a:t>I am still behind schoolbook at 2,048 limbs: 4.6 ms against 4.0 ms.</a:t>
+              <a:t>I pass schoolbook at 4,096 limbs: 9.6 ms against 14.9 ms.</a:t>
             </a:r>
           </a:p>
           <a:p>
@@ -4425,13 +4441,13 @@
               </a:spcAft>
             </a:pPr>
             <a:r>
-              <a:rPr sz="2400" b="0">
+              <a:rPr sz="2200" b="0">
                 <a:solidFill>
                   <a:srgbClr val="1C1917"/>
                 </a:solidFill>
                 <a:latin typeface="Calibri"/>
               </a:rPr>
-              <a:t>I pass the FFT at 8,192 limbs: 20.9 ms against 27.8 ms.</a:t>
+              <a:t>I am still behind schoolbook at 2,048 limbs: 4.3 ms against 3.6 ms.</a:t>
             </a:r>
           </a:p>
           <a:p>
@@ -4441,13 +4457,29 @@
               </a:spcAft>
             </a:pPr>
             <a:r>
-              <a:rPr sz="2400" b="0">
+              <a:rPr sz="2200" b="0">
                 <a:solidFill>
                   <a:srgbClr val="1C1917"/>
                 </a:solidFill>
                 <a:latin typeface="Calibri"/>
               </a:rPr>
-              <a:t>At 16,384 limbs: mine 43 ms, FFT 66 ms, schoolbook 233 ms, GMP 2.9 ms.</a:t>
+              <a:t>I am still behind the FFT at 8,192 limbs: 20.1 ms against 11.4 ms.</a:t>
+            </a:r>
+          </a:p>
+          <a:p>
+            <a:pPr>
+              <a:spcAft>
+                <a:spcPts val="1400"/>
+              </a:spcAft>
+            </a:pPr>
+            <a:r>
+              <a:rPr sz="2200" b="0">
+                <a:solidFill>
+                  <a:srgbClr val="1C1917"/>
+                </a:solidFill>
+                <a:latin typeface="Calibri"/>
+              </a:rPr>
+              <a:t>At 16,384 limbs I edge the FFT: 44.1 ms against 47.5 ms. Karatsuba is 18.4 ms. GMP is 2.6 ms.</a:t>
             </a:r>
           </a:p>
         </p:txBody>

</xml_diff>